<commit_message>
finalized week 9 log from auditing
</commit_message>
<xml_diff>
--- a/Academic Documents/Powerpoint wkg/Mid project Update - Dave v1.1 14-09.pptx
+++ b/Academic Documents/Powerpoint wkg/Mid project Update - Dave v1.1 14-09.pptx
@@ -9569,7 +9569,7 @@
               <a:rPr lang="en-NZ" dirty="0">
                 <a:latin typeface="Century Gothic" panose="020B0502020202020204" pitchFamily="34" charset="0"/>
               </a:rPr>
-              <a:t>Client feedback and questions </a:t>
+              <a:t>Client Feedback and Questions </a:t>
             </a:r>
           </a:p>
         </p:txBody>
@@ -10202,7 +10202,19 @@
               <a:rPr lang="en-NZ" dirty="0">
                 <a:latin typeface="Century Gothic" panose="020B0502020202020204" pitchFamily="34" charset="0"/>
               </a:rPr>
-              <a:t>Brief description of project.</a:t>
+              <a:t>Brief description </a:t>
+            </a:r>
+            <a:r>
+              <a:rPr lang="en-NZ">
+                <a:latin typeface="Century Gothic" panose="020B0502020202020204" pitchFamily="34" charset="0"/>
+              </a:rPr>
+              <a:t>of the project</a:t>
+            </a:r>
+            <a:r>
+              <a:rPr lang="en-NZ" dirty="0">
+                <a:latin typeface="Century Gothic" panose="020B0502020202020204" pitchFamily="34" charset="0"/>
+              </a:rPr>
+              <a:t>.</a:t>
             </a:r>
           </a:p>
         </p:txBody>
@@ -10665,7 +10677,7 @@
           <a:p>
             <a:r>
               <a:rPr lang="en-NZ" dirty="0"/>
-              <a:t>Foremost Proof of Concept</a:t>
+              <a:t>Foremost proof of concept</a:t>
             </a:r>
           </a:p>
         </p:txBody>
@@ -10815,7 +10827,7 @@
           <a:p>
             <a:r>
               <a:rPr lang="en-NZ" dirty="0"/>
-              <a:t>Emerging Insights</a:t>
+              <a:t>Emerging insights</a:t>
             </a:r>
           </a:p>
         </p:txBody>

</xml_diff>